<commit_message>
Retrain MLP on improved synthetic generator (v1.1.0-synth); verify end-to-end
- ai-service/train_models_v2.py: richer latent structure (ability/effort/risk),
  6k rows; honesty guards (warn R2>0.97, fail if below baseline).
- Real measured improvement (validation): R2 0.6709->0.7573, MAE 5.81->5.07,
  RMSE 7.19->6.32, risk F1 0.8211->0.8598; beats both baselines; no leakage.
  LSTM unchanged (val RMSE 0.24971).
- Verified live through Java->AI: POST /api/ai/predict/{id} returns
  modelVersion 1.1.0-synth; low performer -> score 29.79 at_risk=true,
  high performer -> score 100.0 at_risk=false.
- Re-ran suites: smoke 23/23, verify-ai 19/19, pytest 14/14.
- Updated QA log, MIS report and rebuilt report/deck with v2 metrics.
</commit_message>
<xml_diff>
--- a/docs/USAMIS_Presentation.pptx
+++ b/docs/USAMIS_Presentation.pptx
@@ -4564,7 +4564,7 @@
                     <a:p>
                       <a:r>
                         <a:rPr sz="1100"/>
-                        <a:t>0.6709</a:t>
+                        <a:t>0.7573</a:t>
                       </a:r>
                     </a:p>
                   </a:txBody>
@@ -4605,7 +4605,7 @@
                     <a:p>
                       <a:r>
                         <a:rPr sz="1100"/>
-                        <a:t>5.8126 / 7.1903</a:t>
+                        <a:t>5.0688 / 6.3194</a:t>
                       </a:r>
                     </a:p>
                   </a:txBody>
@@ -4646,7 +4646,7 @@
                     <a:p>
                       <a:r>
                         <a:rPr sz="1100"/>
-                        <a:t>0.7741 / 0.8741 / 0.8211</a:t>
+                        <a:t>0.8185 / 0.9055 / 0.8598</a:t>
                       </a:r>
                     </a:p>
                   </a:txBody>

</xml_diff>